<commit_message>
Speaker decks: complete QR coverage — patch Mark Stanley/Shane/Steve dupe; add survey slide to Mark Winters/Beth
</commit_message>
<xml_diff>
--- a/deliverables/speaker-decks/Shane_Spillers_We_Run_on_EOS_2026_Deck.pptx
+++ b/deliverables/speaker-decks/Shane_Spillers_We_Run_on_EOS_2026_Deck.pptx
@@ -9531,6 +9531,30 @@
           </a:p>
         </p:txBody>
       </p:sp>
+      <p:pic>
+        <p:nvPicPr>
+          <p:cNvPr id="9" name="Picture 8" descr="feedback-qr.jpg"/>
+          <p:cNvPicPr>
+            <a:picLocks noChangeAspect="1"/>
+          </p:cNvPicPr>
+          <p:nvPr/>
+        </p:nvPicPr>
+        <p:blipFill>
+          <a:blip r:embed="rId3"/>
+          <a:stretch>
+            <a:fillRect/>
+          </a:stretch>
+        </p:blipFill>
+        <p:spPr>
+          <a:xfrm>
+            <a:off x="12968302" y="3300376"/>
+            <a:ext cx="3686157" cy="3686157"/>
+          </a:xfrm>
+          <a:prstGeom prst="rect">
+            <a:avLst/>
+          </a:prstGeom>
+        </p:spPr>
+      </p:pic>
     </p:spTree>
   </p:cSld>
   <p:clrMapOvr>

</xml_diff>